<commit_message>
Elaine series: all 15 posts built with the final collages, layout fixes, render README with open placeholders
Co-Authored-By: Claude Opus 5.5 <noreply@anthropic.com>
Claude-Session: https://claude.ai/code/session_014HGzAbxBh54nuyJHG7tse8
</commit_message>
<xml_diff>
--- a/templates/posts/november/14-11-2026-sat-ig-3-18-42.pptx
+++ b/templates/posts/november/14-11-2026-sat-ig-3-18-42.pptx
@@ -5008,92 +5008,33 @@
           </a:p>
         </p:txBody>
       </p:sp>
-      <p:sp>
-        <p:nvSpPr>
-          <p:cNvPr id="3" name="Rectangle 2"/>
-          <p:cNvSpPr/>
+      <p:pic>
+        <p:nvPicPr>
+          <p:cNvPr id="3" name="Picture 2" descr="trim-periodic-table-1.png"/>
+          <p:cNvPicPr>
+            <a:picLocks noChangeAspect="1"/>
+          </p:cNvPicPr>
           <p:nvPr/>
-        </p:nvSpPr>
-        <p:spPr>
-          <a:xfrm>
-            <a:off x="762000" y="6381750"/>
-            <a:ext cx="8763000" cy="4953000"/>
+        </p:nvPicPr>
+        <p:blipFill>
+          <a:blip r:embed="rId3"/>
+          <a:stretch>
+            <a:fillRect/>
+          </a:stretch>
+        </p:blipFill>
+        <p:spPr>
+          <a:xfrm>
+            <a:off x="1887402" y="6381750"/>
+            <a:ext cx="6512195" cy="4953000"/>
           </a:xfrm>
           <a:prstGeom prst="rect">
             <a:avLst/>
           </a:prstGeom>
-          <a:solidFill>
-            <a:srgbClr val="D9D4C7"/>
-          </a:solidFill>
-          <a:ln>
-            <a:noFill/>
-          </a:ln>
-          <a:effectLst/>
-        </p:spPr>
-        <p:style>
-          <a:lnRef idx="1">
-            <a:schemeClr val="accent1"/>
-          </a:lnRef>
-          <a:fillRef idx="3">
-            <a:schemeClr val="accent1"/>
-          </a:fillRef>
-          <a:effectRef idx="2">
-            <a:schemeClr val="accent1"/>
-          </a:effectRef>
-          <a:fontRef idx="minor">
-            <a:schemeClr val="lt1"/>
-          </a:fontRef>
-        </p:style>
-        <p:txBody>
-          <a:bodyPr rtlCol="0" anchor="ctr"/>
-          <a:lstStyle/>
-          <a:p>
-            <a:pPr algn="ctr"/>
-          </a:p>
-        </p:txBody>
-      </p:sp>
+        </p:spPr>
+      </p:pic>
       <p:sp>
         <p:nvSpPr>
           <p:cNvPr id="4" name="TextBox 3"/>
-          <p:cNvSpPr txBox="1"/>
-          <p:nvPr/>
-        </p:nvSpPr>
-        <p:spPr>
-          <a:xfrm>
-            <a:off x="1047750" y="6381750"/>
-            <a:ext cx="8191500" cy="4953000"/>
-          </a:xfrm>
-          <a:prstGeom prst="rect">
-            <a:avLst/>
-          </a:prstGeom>
-          <a:noFill/>
-        </p:spPr>
-        <p:txBody>
-          <a:bodyPr wrap="square" lIns="0" rIns="0" tIns="0" bIns="0" anchor="ctr">
-            <a:spAutoFit/>
-          </a:bodyPr>
-          <a:lstStyle/>
-          <a:p>
-            <a:pPr algn="ctr">
-              <a:lnSpc>
-                <a:spcPct val="120000"/>
-              </a:lnSpc>
-            </a:pPr>
-            <a:r>
-              <a:rPr sz="2400" b="1" i="0">
-                <a:solidFill>
-                  <a:srgbClr val="4A463F"/>
-                </a:solidFill>
-                <a:latin typeface="Montserrat"/>
-              </a:rPr>
-              <a:t>COLLAGE: periodic-table-1.png</a:t>
-            </a:r>
-          </a:p>
-        </p:txBody>
-      </p:sp>
-      <p:sp>
-        <p:nvSpPr>
-          <p:cNvPr id="5" name="TextBox 4"/>
           <p:cNvSpPr txBox="1"/>
           <p:nvPr/>
         </p:nvSpPr>
@@ -5132,7 +5073,7 @@
       </p:sp>
       <p:sp>
         <p:nvSpPr>
-          <p:cNvPr id="6" name="TextBox 5"/>
+          <p:cNvPr id="5" name="TextBox 4"/>
           <p:cNvSpPr txBox="1"/>
           <p:nvPr/>
         </p:nvSpPr>
@@ -5171,14 +5112,14 @@
       </p:sp>
       <p:pic>
         <p:nvPicPr>
-          <p:cNvPr id="7" name="Picture 6" descr="foundation-logo-color.png"/>
+          <p:cNvPr id="6" name="Picture 5" descr="foundation-logo-color.png"/>
           <p:cNvPicPr>
             <a:picLocks noChangeAspect="1"/>
           </p:cNvPicPr>
           <p:nvPr/>
         </p:nvPicPr>
         <p:blipFill>
-          <a:blip r:embed="rId3"/>
+          <a:blip r:embed="rId4"/>
           <a:stretch>
             <a:fillRect/>
           </a:stretch>

</xml_diff>